<commit_message>
Update slides and add dice illustration
</commit_message>
<xml_diff>
--- a/intro_genAI_slides.pptx
+++ b/intro_genAI_slides.pptx
@@ -4345,25 +4345,71 @@
           <a:p>
             <a:pPr/>
             <a:r>
-              <a:t>1. AI のなかみ</a:t>
-            </a:r>
-          </a:p>
-          <a:p>
-            <a:pPr/>
-            <a:r>
-              <a:t>2. AI の並び替え </a:t>
-            </a:r>
-          </a:p>
-          <a:p>
-            <a:pPr/>
-            <a:r>
-              <a:t>3. AI の提案</a:t>
-            </a:r>
-          </a:p>
-          <a:p>
-            <a:pPr/>
-            <a:r>
-              <a:t>4. AI と人間</a:t>
+              <a:t>1. </a:t>
+            </a:r>
+            <a:r>
+              <a:rPr>
+                <a:solidFill>
+                  <a:srgbClr val="D4FB79"/>
+                </a:solidFill>
+              </a:rPr>
+              <a:t>AI のなかみ</a:t>
+            </a:r>
+          </a:p>
+          <a:p>
+            <a:pPr/>
+            <a:r>
+              <a:t>2. </a:t>
+            </a:r>
+            <a:r>
+              <a:rPr>
+                <a:solidFill>
+                  <a:srgbClr val="FF85FF"/>
+                </a:solidFill>
+              </a:rPr>
+              <a:t>AI の並び替え</a:t>
+            </a:r>
+            <a:r>
+              <a:t> </a:t>
+            </a:r>
+          </a:p>
+          <a:p>
+            <a:pPr/>
+            <a:r>
+              <a:t>3. </a:t>
+            </a:r>
+            <a:r>
+              <a:rPr>
+                <a:solidFill>
+                  <a:srgbClr val="FF7E79"/>
+                </a:solidFill>
+              </a:rPr>
+              <a:t>AI の提案</a:t>
+            </a:r>
+          </a:p>
+          <a:p>
+            <a:pPr/>
+            <a:r>
+              <a:t>4. </a:t>
+            </a:r>
+            <a:r>
+              <a:rPr>
+                <a:solidFill>
+                  <a:srgbClr val="73FDFF"/>
+                </a:solidFill>
+              </a:rPr>
+              <a:t>AI と人間</a:t>
+            </a:r>
+            <a:endParaRPr>
+              <a:solidFill>
+                <a:srgbClr val="73FDFF"/>
+              </a:solidFill>
+            </a:endParaRPr>
+          </a:p>
+          <a:p>
+            <a:pPr/>
+            <a:r>
+              <a:t>5. 実習</a:t>
             </a:r>
           </a:p>
         </p:txBody>
@@ -4417,7 +4463,11 @@
               <a:spcBef>
                 <a:spcPts val="1800"/>
               </a:spcBef>
-              <a:defRPr b="0" spc="-55" sz="5500"/>
+              <a:defRPr b="0" spc="-55" sz="5500">
+                <a:solidFill>
+                  <a:srgbClr val="FFFC79"/>
+                </a:solidFill>
+              </a:defRPr>
             </a:lvl1pPr>
           </a:lstStyle>
           <a:p>
@@ -4459,7 +4509,7 @@
       </p:sp>
       <p:sp>
         <p:nvSpPr>
-          <p:cNvPr id="181" name="インターネットから持ってくることができるデータ…"/>
+          <p:cNvPr id="181" name="主にインターネットから持ってくることができるデータを持っている…"/>
           <p:cNvSpPr txBox="1"/>
           <p:nvPr>
             <p:ph type="body" idx="1"/>
@@ -4476,17 +4526,52 @@
           <a:p>
             <a:pPr lvl="2"/>
             <a:r>
-              <a:t>インターネットから持ってくることができるデータ</a:t>
+              <a:t>主にインターネットから持ってくることができるデータを持っている</a:t>
             </a:r>
           </a:p>
           <a:p>
             <a:pPr lvl="2"/>
             <a:r>
-              <a:t>目的別に正解データを足して専用に答える工夫</a:t>
-            </a:r>
-          </a:p>
-        </p:txBody>
-      </p:sp>
+              <a:t>目的別に正解データを足して専用に答える準備 (サイコロづくり)</a:t>
+            </a:r>
+          </a:p>
+          <a:p>
+            <a:pPr lvl="2"/>
+            <a:r>
+              <a:t>答えるときは偏ったサイコロ</a:t>
+            </a:r>
+          </a:p>
+        </p:txBody>
+      </p:sp>
+      <p:pic>
+        <p:nvPicPr>
+          <p:cNvPr id="182" name="Gemini_Generated_Image_kvwlfckvwlfckvwl.jpg" descr="Gemini_Generated_Image_kvwlfckvwlfckvwl.jpg"/>
+          <p:cNvPicPr>
+            <a:picLocks noChangeAspect="1"/>
+          </p:cNvPicPr>
+          <p:nvPr/>
+        </p:nvPicPr>
+        <p:blipFill>
+          <a:blip r:embed="rId2">
+            <a:extLst/>
+          </a:blip>
+          <a:stretch>
+            <a:fillRect/>
+          </a:stretch>
+        </p:blipFill>
+        <p:spPr>
+          <a:xfrm>
+            <a:off x="14540962" y="8554880"/>
+            <a:ext cx="11876924" cy="6628981"/>
+          </a:xfrm>
+          <a:prstGeom prst="rect">
+            <a:avLst/>
+          </a:prstGeom>
+          <a:ln w="12700">
+            <a:miter lim="400000"/>
+          </a:ln>
+        </p:spPr>
+      </p:pic>
     </p:spTree>
   </p:cSld>
   <p:clrMapOvr>
@@ -4515,7 +4600,7 @@
       </p:grpSpPr>
       <p:sp>
         <p:nvSpPr>
-          <p:cNvPr id="183" name="AI の並び替え"/>
+          <p:cNvPr id="184" name="AI の並び替え"/>
           <p:cNvSpPr txBox="1"/>
           <p:nvPr>
             <p:ph type="title"/>
@@ -4536,7 +4621,11 @@
               <a:spcBef>
                 <a:spcPts val="1800"/>
               </a:spcBef>
-              <a:defRPr b="0" spc="-55" sz="5500"/>
+              <a:defRPr b="0" spc="-55" sz="5500">
+                <a:solidFill>
+                  <a:srgbClr val="FF85FF"/>
+                </a:solidFill>
+              </a:defRPr>
             </a:lvl1pPr>
           </a:lstStyle>
           <a:p>
@@ -4549,7 +4638,7 @@
       </p:sp>
       <p:sp>
         <p:nvSpPr>
-          <p:cNvPr id="184" name="集めたデータを数える"/>
+          <p:cNvPr id="185" name="集めたデータを数える"/>
           <p:cNvSpPr txBox="1"/>
           <p:nvPr>
             <p:ph type="body" idx="21"/>
@@ -4578,7 +4667,7 @@
       </p:sp>
       <p:sp>
         <p:nvSpPr>
-          <p:cNvPr id="185" name="今持っている単語の次に並ぶ単語の確率順に並べる…"/>
+          <p:cNvPr id="186" name="今持っている単語の次に並ぶ単語の確率順に並べる…"/>
           <p:cNvSpPr txBox="1"/>
           <p:nvPr>
             <p:ph type="body" idx="1"/>
@@ -4637,7 +4726,7 @@
       </p:grpSpPr>
       <p:sp>
         <p:nvSpPr>
-          <p:cNvPr id="187" name="AI の提案"/>
+          <p:cNvPr id="188" name="AI の提案"/>
           <p:cNvSpPr txBox="1"/>
           <p:nvPr>
             <p:ph type="title"/>
@@ -4658,7 +4747,11 @@
               <a:spcBef>
                 <a:spcPts val="1800"/>
               </a:spcBef>
-              <a:defRPr b="0" spc="-55" sz="5500"/>
+              <a:defRPr b="0" spc="-55" sz="5500">
+                <a:solidFill>
+                  <a:srgbClr val="FF7E79"/>
+                </a:solidFill>
+              </a:defRPr>
             </a:lvl1pPr>
           </a:lstStyle>
           <a:p>
@@ -4671,7 +4764,7 @@
       </p:sp>
       <p:sp>
         <p:nvSpPr>
-          <p:cNvPr id="188" name="大正解とポジティブとネガティブ"/>
+          <p:cNvPr id="189" name="大正解とポジティブとネガティブ"/>
           <p:cNvSpPr txBox="1"/>
           <p:nvPr>
             <p:ph type="body" idx="21"/>
@@ -4700,7 +4793,7 @@
       </p:sp>
       <p:sp>
         <p:nvSpPr>
-          <p:cNvPr id="189" name="みんなが答えているものの多数を正解として答える…"/>
+          <p:cNvPr id="190" name="みんなが答えているものの多数を正解として答える…"/>
           <p:cNvSpPr txBox="1"/>
           <p:nvPr>
             <p:ph type="body" idx="1"/>
@@ -4717,19 +4810,63 @@
           <a:p>
             <a:pPr/>
             <a:r>
-              <a:t>みんなが答えているものの多数を正解として答える</a:t>
-            </a:r>
-          </a:p>
-          <a:p>
-            <a:pPr/>
-            <a:r>
-              <a:t>ポジティブとネガティブが同じ答えに並んだりする</a:t>
-            </a:r>
-          </a:p>
-          <a:p>
-            <a:pPr/>
-            <a:r>
-              <a:t>よく読むと正しくないこともある</a:t>
+              <a:t>みんなが答えているものの</a:t>
+            </a:r>
+            <a:r>
+              <a:rPr>
+                <a:solidFill>
+                  <a:srgbClr val="FFFB00"/>
+                </a:solidFill>
+              </a:rPr>
+              <a:t>多数を正解</a:t>
+            </a:r>
+            <a:r>
+              <a:t>として答える</a:t>
+            </a:r>
+          </a:p>
+          <a:p>
+            <a:pPr/>
+            <a:r>
+              <a:t>ポジティブとネガティブを</a:t>
+            </a:r>
+            <a:r>
+              <a:rPr>
+                <a:solidFill>
+                  <a:srgbClr val="73FA79"/>
+                </a:solidFill>
+              </a:rPr>
+              <a:t>並べちゃう</a:t>
+            </a:r>
+            <a:r>
+              <a:t>: </a:t>
+            </a:r>
+            <a:r>
+              <a:rPr>
+                <a:solidFill>
+                  <a:srgbClr val="FF2F92"/>
+                </a:solidFill>
+              </a:rPr>
+              <a:t>あなた</a:t>
+            </a:r>
+            <a:r>
+              <a:t>の主張になっている?</a:t>
+            </a:r>
+          </a:p>
+          <a:p>
+            <a:pPr/>
+            <a:r>
+              <a:t>よく読むと</a:t>
+            </a:r>
+            <a:r>
+              <a:rPr>
+                <a:solidFill>
+                  <a:srgbClr val="73FDFF"/>
+                </a:solidFill>
+              </a:rPr>
+              <a:t>正しくない</a:t>
+            </a:r>
+            <a:r>
+              <a:t>こともある: だってサイコロ使って言葉を埋めたから</a:t>
             </a:r>
           </a:p>
         </p:txBody>
@@ -4762,7 +4899,7 @@
       </p:grpSpPr>
       <p:sp>
         <p:nvSpPr>
-          <p:cNvPr id="191" name="AI と人間"/>
+          <p:cNvPr id="192" name="AI と人間"/>
           <p:cNvSpPr txBox="1"/>
           <p:nvPr>
             <p:ph type="title"/>
@@ -4783,7 +4920,11 @@
               <a:spcBef>
                 <a:spcPts val="1800"/>
               </a:spcBef>
-              <a:defRPr b="0" spc="-55" sz="5500"/>
+              <a:defRPr b="0" spc="-55" sz="5500">
+                <a:solidFill>
+                  <a:srgbClr val="73FDFF"/>
+                </a:solidFill>
+              </a:defRPr>
             </a:lvl1pPr>
           </a:lstStyle>
           <a:p>
@@ -4796,7 +4937,7 @@
       </p:sp>
       <p:sp>
         <p:nvSpPr>
-          <p:cNvPr id="192" name="人間は AI に伝わる文章を書けるようになればいい"/>
+          <p:cNvPr id="193" name="人間は AI に伝わる文章を書けるようになればいい"/>
           <p:cNvSpPr txBox="1"/>
           <p:nvPr>
             <p:ph type="body" idx="21"/>
@@ -4818,14 +4959,25 @@
           <a:p>
             <a:pPr/>
             <a:r>
-              <a:t>人間は AI に伝わる文章を書けるようになればいい</a:t>
-            </a:r>
-          </a:p>
-        </p:txBody>
-      </p:sp>
-      <p:sp>
-        <p:nvSpPr>
-          <p:cNvPr id="193" name="AI は大勢の書いた文章とごく少数の専門的な文章から確率的に出される文を正しく並べただけ…"/>
+              <a:t>人間は AI に</a:t>
+            </a:r>
+            <a:r>
+              <a:rPr>
+                <a:solidFill>
+                  <a:srgbClr val="73FDFF"/>
+                </a:solidFill>
+              </a:rPr>
+              <a:t>伝わる文章</a:t>
+            </a:r>
+            <a:r>
+              <a:t>を書けるようになればいい</a:t>
+            </a:r>
+          </a:p>
+        </p:txBody>
+      </p:sp>
+      <p:sp>
+        <p:nvSpPr>
+          <p:cNvPr id="194" name="AI は大勢の書いた文章とごく少数の専門的な文章から確率的に文を並べる…"/>
           <p:cNvSpPr txBox="1"/>
           <p:nvPr>
             <p:ph type="body" idx="1"/>
@@ -4842,26 +4994,65 @@
           <a:p>
             <a:pPr/>
             <a:r>
-              <a:t>AI は大勢の書いた文章とごく少数の専門的な文章から確率的に出される文を正しく並べただけ</a:t>
-            </a:r>
-          </a:p>
-          <a:p>
-            <a:pPr/>
-            <a:r>
-              <a:t>人間は最初の設定をプログラミング的に説明すると AI の答えは必要なことを穴埋めしてくれることが期待できる</a:t>
-            </a:r>
-          </a:p>
-          <a:p>
-            <a:pPr/>
-            <a:r>
-              <a:t>更新頻度が高いので明日は別のしくみで答えが出るかもしれない</a:t>
-            </a:r>
-          </a:p>
-        </p:txBody>
-      </p:sp>
-      <p:sp>
-        <p:nvSpPr>
-          <p:cNvPr id="194" name="答えを説明できる力を身につけるべし"/>
+              <a:t>AI は大勢の書いた文章とごく少数の専門的な文章から確率的に文を並べる</a:t>
+            </a:r>
+          </a:p>
+          <a:p>
+            <a:pPr/>
+            <a:r>
+              <a:t> 人間は設定説明: </a:t>
+            </a:r>
+            <a:r>
+              <a:rPr>
+                <a:solidFill>
+                  <a:srgbClr val="FFFB00"/>
+                </a:solidFill>
+              </a:rPr>
+              <a:t>Markdown</a:t>
+            </a:r>
+            <a:r>
+              <a:t> が伝わるよ　&lt;Notebook の書き方&gt;</a:t>
+            </a:r>
+          </a:p>
+          <a:p>
+            <a:pPr/>
+            <a:r>
+              <a:t>AI は必要なことを</a:t>
+            </a:r>
+            <a:r>
+              <a:rPr>
+                <a:solidFill>
+                  <a:srgbClr val="FF2F92"/>
+                </a:solidFill>
+              </a:rPr>
+              <a:t>穴埋めしてくれる…けど</a:t>
+            </a:r>
+            <a:r>
+              <a:t>?</a:t>
+            </a:r>
+          </a:p>
+          <a:p>
+            <a:pPr/>
+            <a:r>
+              <a:t>更新頻度が高いので明日は</a:t>
+            </a:r>
+            <a:r>
+              <a:rPr>
+                <a:solidFill>
+                  <a:srgbClr val="73FA79"/>
+                </a:solidFill>
+              </a:rPr>
+              <a:t>別のしくみ</a:t>
+            </a:r>
+            <a:r>
+              <a:t>で答えが出るかもしれない</a:t>
+            </a:r>
+          </a:p>
+        </p:txBody>
+      </p:sp>
+      <p:sp>
+        <p:nvSpPr>
+          <p:cNvPr id="195" name="答えを説明できる力を身につけるべし"/>
           <p:cNvSpPr txBox="1"/>
           <p:nvPr/>
         </p:nvSpPr>
@@ -4923,7 +5114,7 @@
       </p:grpSpPr>
       <p:sp>
         <p:nvSpPr>
-          <p:cNvPr id="196" name="データ"/>
+          <p:cNvPr id="197" name="データ"/>
           <p:cNvSpPr txBox="1"/>
           <p:nvPr>
             <p:ph type="title"/>
@@ -4947,7 +5138,7 @@
       </p:sp>
       <p:sp>
         <p:nvSpPr>
-          <p:cNvPr id="197" name="りんごとのりまき"/>
+          <p:cNvPr id="198" name="りんごとのりまき"/>
           <p:cNvSpPr txBox="1"/>
           <p:nvPr>
             <p:ph type="body" idx="21"/>
@@ -4976,7 +5167,7 @@
       </p:sp>
       <p:sp>
         <p:nvSpPr>
-          <p:cNvPr id="198" name="りんごは丸い…"/>
+          <p:cNvPr id="199" name="りんごは丸い…"/>
           <p:cNvSpPr txBox="1"/>
           <p:nvPr>
             <p:ph type="body" sz="half" idx="1"/>
@@ -5030,7 +5221,7 @@
       </p:sp>
       <p:pic>
         <p:nvPicPr>
-          <p:cNvPr id="199" name="Gemini_Generated_Image_26xmqa26xmqa26xm.jpg" descr="Gemini_Generated_Image_26xmqa26xmqa26xm.jpg"/>
+          <p:cNvPr id="200" name="Gemini_Generated_Image_26xmqa26xmqa26xm.jpg" descr="Gemini_Generated_Image_26xmqa26xmqa26xm.jpg"/>
           <p:cNvPicPr>
             <a:picLocks noChangeAspect="1"/>
           </p:cNvPicPr>
@@ -5050,7 +5241,7 @@
         <p:spPr>
           <a:xfrm>
             <a:off x="11912600" y="2294958"/>
-            <a:ext cx="10922000" cy="9126481"/>
+            <a:ext cx="10922001" cy="9126481"/>
           </a:xfrm>
           <a:prstGeom prst="rect">
             <a:avLst/>
@@ -5090,7 +5281,7 @@
       </p:grpSpPr>
       <p:sp>
         <p:nvSpPr>
-          <p:cNvPr id="201" name="のりまきとりんごを説明する AI による提案"/>
+          <p:cNvPr id="202" name="のりまきとりんごを説明する AI による提案"/>
           <p:cNvSpPr txBox="1"/>
           <p:nvPr>
             <p:ph type="title"/>
@@ -5114,7 +5305,7 @@
       </p:sp>
       <p:sp>
         <p:nvSpPr>
-          <p:cNvPr id="202" name="どんなことをいいそうなのか"/>
+          <p:cNvPr id="203" name="どんなことをいいそうなのか"/>
           <p:cNvSpPr txBox="1"/>
           <p:nvPr>
             <p:ph type="body" idx="21"/>
@@ -5143,7 +5334,7 @@
       </p:sp>
       <p:sp>
         <p:nvSpPr>
-          <p:cNvPr id="203" name="1. 出てくる数を数える…"/>
+          <p:cNvPr id="204" name="1. 出てくる数を数える…"/>
           <p:cNvSpPr txBox="1"/>
           <p:nvPr>
             <p:ph type="body" idx="1"/>
@@ -5261,7 +5452,7 @@
       </p:grpSpPr>
       <p:sp>
         <p:nvSpPr>
-          <p:cNvPr id="205" name="AI と人間 AGAIN"/>
+          <p:cNvPr id="206" name="AI と人間 AGAIN"/>
           <p:cNvSpPr txBox="1"/>
           <p:nvPr>
             <p:ph type="title"/>
@@ -5274,7 +5465,15 @@
         </p:spPr>
         <p:txBody>
           <a:bodyPr/>
-          <a:lstStyle/>
+          <a:lstStyle>
+            <a:lvl1pPr>
+              <a:defRPr>
+                <a:solidFill>
+                  <a:srgbClr val="4F8F00"/>
+                </a:solidFill>
+              </a:defRPr>
+            </a:lvl1pPr>
+          </a:lstStyle>
           <a:p>
             <a:pPr/>
             <a:r>
@@ -5285,7 +5484,7 @@
       </p:sp>
       <p:sp>
         <p:nvSpPr>
-          <p:cNvPr id="206" name="提案されたものから考えよう"/>
+          <p:cNvPr id="207" name="提案されたものから考えよう"/>
           <p:cNvSpPr txBox="1"/>
           <p:nvPr>
             <p:ph type="body" idx="21"/>
@@ -5314,7 +5513,7 @@
       </p:sp>
       <p:sp>
         <p:nvSpPr>
-          <p:cNvPr id="207" name="確率的に出された答えは果たして自分が必要な答えになっているのか？…"/>
+          <p:cNvPr id="208" name="確率的に出された答えは果たして自分が必要な答えになっているのか？…"/>
           <p:cNvSpPr txBox="1"/>
           <p:nvPr>
             <p:ph type="body" idx="1"/>
@@ -5331,19 +5530,52 @@
           <a:p>
             <a:pPr/>
             <a:r>
-              <a:t>確率的に出された答えは果たして自分が必要な答えになっているのか？</a:t>
+              <a:t>確率的に出された答えは果たして</a:t>
+            </a:r>
+            <a:r>
+              <a:rPr>
+                <a:solidFill>
+                  <a:srgbClr val="D783FF"/>
+                </a:solidFill>
+              </a:rPr>
+              <a:t>自分が必要な答え</a:t>
+            </a:r>
+            <a:r>
+              <a:t>になっているのか？</a:t>
             </a:r>
           </a:p>
           <a:p>
             <a:pPr lvl="2"/>
             <a:r>
-              <a:t>“必要” には裏付けが含まれる</a:t>
+              <a:t>“必要” には</a:t>
+            </a:r>
+            <a:r>
+              <a:rPr>
+                <a:solidFill>
+                  <a:srgbClr val="D4FB79"/>
+                </a:solidFill>
+              </a:rPr>
+              <a:t>裏付け</a:t>
+            </a:r>
+            <a:r>
+              <a:t>が含まれる</a:t>
             </a:r>
           </a:p>
           <a:p>
             <a:pPr lvl="2"/>
             <a:r>
-              <a:t>いわばサイコロを振って出された文であることを自覚する</a:t>
+              <a:t>いわばサイコロを振って</a:t>
+            </a:r>
+            <a:r>
+              <a:rPr>
+                <a:solidFill>
+                  <a:srgbClr val="7A81FF"/>
+                </a:solidFill>
+              </a:rPr>
+              <a:t>無責任に出てきた文</a:t>
+            </a:r>
+            <a:r>
+              <a:t>であることを自覚する</a:t>
             </a:r>
           </a:p>
         </p:txBody>

</xml_diff>